<commit_message>
Smart-RUDP in chat: RTT-paced decisions, loss-event signal, utilisation reward; docs updated
Co-Authored-By: Claude Sonnet 5.5 <noreply@anthropic.com>
Claude-Session: https://claude.ai/code/session_01NX2zRNpdVAnzFNKmqomzKu
</commit_message>
<xml_diff>
--- a/docs/final/RUDP_Presentation_with_notes.pptx
+++ b/docs/final/RUDP_Presentation_with_notes.pptx
@@ -1602,7 +1602,7 @@
           </a:p>
           <a:p>
             <a:r>
-              <a:t>- There is a controller switch: fixed window, AIMD, or Smart-RUDP, which loads the trained table and keeps learning live. A 60-message test button times delivery. Honest result: Smart-RUDP did not beat the simple rules here either.</a:t>
+              <a:t>- There is a controller switch: fixed window, AIMD, or Smart-RUDP, which loads the trained table and keeps learning live. A 60-message test button times delivery. Honest result: no consistent winner; Smart-RUDP did not clearly beat the simple rules, same as the experiments.</a:t>
             </a:r>
           </a:p>
           <a:p/>
@@ -6732,7 +6732,7 @@
                 <a:ea typeface="Calibri" pitchFamily="34" charset="-122"/>
                 <a:cs typeface="Calibri" pitchFamily="34" charset="-120"/>
               </a:rPr>
-              <a:t>60-message test: Smart-RUDP did not beat the simple rules, same as Section 8</a:t>
+              <a:t>60-message test: no consistent winner, Smart-RUDP not clearly better, same as Section 8</a:t>
             </a:r>
             <a:endParaRPr lang="en-US" sz="1600" dirty="0"/>
           </a:p>

</xml_diff>